<commit_message>
hygiene: strip machine paths and venv refs, remove em dashes from tracked text, fix deck XML dashes (v1/v2)
</commit_message>
<xml_diff>
--- a/assets/Kavach_IIC3_deck.pptx
+++ b/assets/Kavach_IIC3_deck.pptx
@@ -11427,7 +11427,7 @@
                 <a:cs typeface="Poppins Light"/>
                 <a:sym typeface="Poppins Light"/>
               </a:rPr>
-              <a:t>Kavach — Real-Time AI Voice-Clone Detection for UPI &amp; Voice Banking</a:t>
+              <a:t>Kavach - Real-Time AI Voice-Clone Detection for UPI &amp; Voice Banking</a:t>
             </a:r>
             <a:endParaRPr dirty="0"/>
           </a:p>
@@ -11480,7 +11480,7 @@
                 <a:cs typeface="Poppins Light"/>
                 <a:sym typeface="Poppins Light"/>
               </a:rPr>
-              <a:t>Team Name: {{TEAM_NAME}}</a:t>
+              <a:t>Team Name: 511</a:t>
             </a:r>
             <a:endParaRPr dirty="0"/>
           </a:p>
@@ -12883,7 +12883,7 @@
                 <a:cs typeface="Playfair Display"/>
                 <a:sym typeface="Playfair Display"/>
               </a:rPr>
-              <a:t>KAVACH — SPOOF-SCORE EVERY VOICE, BEFORE THE PAYMENT</a:t>
+              <a:t>KAVACH - SPOOF-SCORE EVERY VOICE, BEFORE THE PAYMENT</a:t>
             </a:r>
             <a:endParaRPr dirty="0"/>
           </a:p>
@@ -14493,7 +14493,7 @@
                 <a:cs typeface="Poppins Light"/>
                 <a:sym typeface="Poppins Light"/>
               </a:rPr>
-              <a:t>663+ banks, 79+ apps on UPI — every voice channel is a target surface</a:t>
+              <a:t>663+ banks, 79+ apps on UPI - every voice channel is a target surface</a:t>
             </a:r>
             <a:endParaRPr dirty="0"/>
           </a:p>
@@ -15333,7 +15333,7 @@
                 <a:cs typeface="Playfair Display"/>
                 <a:sym typeface="Playfair Display"/>
               </a:rPr>
-              <a:t>WORKING PROTOTYPE — LIVE DEMO</a:t>
+              <a:t>WORKING PROTOTYPE - LIVE DEMO</a:t>
             </a:r>
             <a:endParaRPr dirty="0"/>
           </a:p>

</xml_diff>